<commit_message>
Clarify self-evolving memory design and align twelve-page paper
</commit_message>
<xml_diff>
--- a/figures/pptx/figure3-memory-system-reference1-v7.pptx
+++ b/figures/pptx/figure3-memory-system-reference1-v7.pptx
@@ -9788,11 +9788,7 @@
             </a:lvl9pPr>
           </a:lstStyle>
           <a:p>
-            <a:pPr algn="l">
-              <a:lnSpc>
-                <a:spcPct val="100000"/>
-              </a:lnSpc>
-              <a:buNone/>
+            <a:pPr>
               <a:defRPr sz="1800" b="1" i="0">
                 <a:solidFill>
                   <a:srgbClr val="FFFFFF"/>
@@ -9803,16 +9799,17 @@
               </a:defRPr>
             </a:pPr>
             <a:r>
-              <a:rPr sz="1800" b="1" i="0" dirty="0">
-                <a:solidFill>
-                  <a:srgbClr val="FFFFFF"/>
-                </a:solidFill>
-                <a:latin typeface="Arial Rounded MT Bold"/>
-                <a:ea typeface="Arial Rounded MT Bold"/>
-                <a:cs typeface="Arial Rounded MT Bold"/>
-              </a:rPr>
-              <a:t>For Performance</a:t>
+              <a:rPr lang="en" dirty="0"/>
+              <a:t>For Accuracy</a:t>
             </a:r>
+            <a:endParaRPr sz="1800" b="1" i="0" dirty="0">
+              <a:solidFill>
+                <a:srgbClr val="FFFFFF"/>
+              </a:solidFill>
+              <a:latin typeface="Arial Rounded MT Bold"/>
+              <a:ea typeface="Arial Rounded MT Bold"/>
+              <a:cs typeface="Arial Rounded MT Bold"/>
+            </a:endParaRPr>
           </a:p>
         </p:txBody>
       </p:sp>
@@ -22156,11 +22153,7 @@
             </a:lvl9pPr>
           </a:lstStyle>
           <a:p>
-            <a:pPr algn="l">
-              <a:lnSpc>
-                <a:spcPct val="100000"/>
-              </a:lnSpc>
-              <a:buNone/>
+            <a:pPr>
               <a:defRPr sz="1800" b="1" i="0">
                 <a:solidFill>
                   <a:srgbClr val="FFFFFF"/>
@@ -22171,16 +22164,17 @@
               </a:defRPr>
             </a:pPr>
             <a:r>
-              <a:rPr sz="1800" b="1" i="0" dirty="0">
-                <a:solidFill>
-                  <a:srgbClr val="FFFFFF"/>
-                </a:solidFill>
-                <a:latin typeface="Arial Rounded MT Bold"/>
-                <a:ea typeface="Arial Rounded MT Bold"/>
-                <a:cs typeface="Arial Rounded MT Bold"/>
-              </a:rPr>
-              <a:t>For Efficiency</a:t>
+              <a:rPr lang="en"/>
+              <a:t>For Cost</a:t>
             </a:r>
+            <a:endParaRPr sz="1800" b="1" i="0" dirty="0">
+              <a:solidFill>
+                <a:srgbClr val="FFFFFF"/>
+              </a:solidFill>
+              <a:latin typeface="Arial Rounded MT Bold"/>
+              <a:ea typeface="Arial Rounded MT Bold"/>
+              <a:cs typeface="Arial Rounded MT Bold"/>
+            </a:endParaRPr>
           </a:p>
         </p:txBody>
       </p:sp>

</xml_diff>

<commit_message>
Align manuscript with revised introduction and finalize twelve-page body
</commit_message>
<xml_diff>
--- a/figures/pptx/figure3-memory-system-reference1-v7.pptx
+++ b/figures/pptx/figure3-memory-system-reference1-v7.pptx
@@ -35667,8 +35667,38 @@
                 <a:ea typeface="Arial Rounded MT Bold"/>
                 <a:cs typeface="Arial Rounded MT Bold"/>
               </a:rPr>
-              <a:t>Query-specific pipelines</a:t>
+              <a:t>Query</a:t>
             </a:r>
+            <a:r>
+              <a:rPr lang="zh-CN" altLang="en-US" sz="1800" b="1" i="0" dirty="0">
+                <a:solidFill>
+                  <a:srgbClr val="171717"/>
+                </a:solidFill>
+                <a:latin typeface="Arial Rounded MT Bold"/>
+                <a:ea typeface="Arial Rounded MT Bold"/>
+                <a:cs typeface="Arial Rounded MT Bold"/>
+              </a:rPr>
+              <a:t> </a:t>
+            </a:r>
+            <a:r>
+              <a:rPr lang="en-US" altLang="zh-CN" sz="1800" b="1" i="0" dirty="0">
+                <a:solidFill>
+                  <a:srgbClr val="171717"/>
+                </a:solidFill>
+                <a:latin typeface="Arial Rounded MT Bold"/>
+                <a:ea typeface="Arial Rounded MT Bold"/>
+                <a:cs typeface="Arial Rounded MT Bold"/>
+              </a:rPr>
+              <a:t>Planning</a:t>
+            </a:r>
+            <a:endParaRPr sz="1800" b="1" i="0" dirty="0">
+              <a:solidFill>
+                <a:srgbClr val="171717"/>
+              </a:solidFill>
+              <a:latin typeface="Arial Rounded MT Bold"/>
+              <a:ea typeface="Arial Rounded MT Bold"/>
+              <a:cs typeface="Arial Rounded MT Bold"/>
+            </a:endParaRPr>
           </a:p>
         </p:txBody>
       </p:sp>
@@ -35821,7 +35851,7 @@
               </a:defRPr>
             </a:pPr>
             <a:r>
-              <a:rPr sz="1800" b="1" i="0">
+              <a:rPr sz="1800" b="1" i="0" dirty="0">
                 <a:solidFill>
                   <a:srgbClr val="171717"/>
                 </a:solidFill>
@@ -35829,7 +35859,29 @@
                 <a:ea typeface="Arial Rounded MT Bold"/>
                 <a:cs typeface="Arial Rounded MT Bold"/>
               </a:rPr>
-              <a:t>Cost-aware execution</a:t>
+              <a:t>Cost-aware </a:t>
+            </a:r>
+            <a:r>
+              <a:rPr lang="en-US" altLang="zh-CN" sz="1800" b="1" i="0" dirty="0">
+                <a:solidFill>
+                  <a:srgbClr val="171717"/>
+                </a:solidFill>
+                <a:latin typeface="Arial Rounded MT Bold"/>
+                <a:ea typeface="Arial Rounded MT Bold"/>
+                <a:cs typeface="Arial Rounded MT Bold"/>
+              </a:rPr>
+              <a:t>E</a:t>
+            </a:r>
+            <a:r>
+              <a:rPr sz="1800" b="1" i="0" dirty="0">
+                <a:solidFill>
+                  <a:srgbClr val="171717"/>
+                </a:solidFill>
+                <a:latin typeface="Arial Rounded MT Bold"/>
+                <a:ea typeface="Arial Rounded MT Bold"/>
+                <a:cs typeface="Arial Rounded MT Bold"/>
+              </a:rPr>
+              <a:t>xecution</a:t>
             </a:r>
           </a:p>
         </p:txBody>

</xml_diff>